<commit_message>
Update presentation with Hackverse 2K26 banner and speaker notes
</commit_message>
<xml_diff>
--- a/Code_Titans_CB_SW_4_Presentation.pptx
+++ b/Code_Titans_CB_SW_4_Presentation.pptx
@@ -3194,7 +3194,7 @@
         <p:spPr>
           <a:xfrm>
             <a:off x="914400" y="640080"/>
-            <a:ext cx="4754880" cy="384048"/>
+            <a:ext cx="4937760" cy="384048"/>
           </a:xfrm>
           <a:prstGeom prst="roundRect">
             <a:avLst/>
@@ -3227,21 +3227,75 @@
           <a:lstStyle/>
           <a:p>
             <a:pPr algn="ctr">
-              <a:defRPr sz="1100" b="1">
+              <a:defRPr sz="1050" b="1">
                 <a:solidFill>
                   <a:srgbClr val="FFFFFF"/>
                 </a:solidFill>
               </a:defRPr>
             </a:pPr>
             <a:r>
-              <a:t>🎯 PROBLEM STATEMENT: CB SW 4 • AGRI-TECH &amp; RURAL INNOVATION</a:t>
-            </a:r>
-          </a:p>
-        </p:txBody>
-      </p:sp>
-      <p:sp>
-        <p:nvSpPr>
-          <p:cNvPr id="5" name="TextBox 4"/>
+              <a:t>🎯 PROBLEM STATEMENT: CB SW 4 • AGRI-TECH</a:t>
+            </a:r>
+          </a:p>
+        </p:txBody>
+      </p:sp>
+      <p:sp>
+        <p:nvSpPr>
+          <p:cNvPr id="5" name="Rounded Rectangle 4"/>
+          <p:cNvSpPr/>
+          <p:nvPr/>
+        </p:nvSpPr>
+        <p:spPr>
+          <a:xfrm>
+            <a:off x="6035040" y="640080"/>
+            <a:ext cx="5212080" cy="384048"/>
+          </a:xfrm>
+          <a:prstGeom prst="roundRect">
+            <a:avLst/>
+          </a:prstGeom>
+          <a:solidFill>
+            <a:srgbClr val="1E293B"/>
+          </a:solidFill>
+          <a:ln w="19050">
+            <a:solidFill>
+              <a:srgbClr val="F59E0B"/>
+            </a:solidFill>
+          </a:ln>
+        </p:spPr>
+        <p:style>
+          <a:lnRef idx="1">
+            <a:schemeClr val="accent1"/>
+          </a:lnRef>
+          <a:fillRef idx="3">
+            <a:schemeClr val="accent1"/>
+          </a:fillRef>
+          <a:effectRef idx="2">
+            <a:schemeClr val="accent1"/>
+          </a:effectRef>
+          <a:fontRef idx="minor">
+            <a:schemeClr val="lt1"/>
+          </a:fontRef>
+        </p:style>
+        <p:txBody>
+          <a:bodyPr rtlCol="0" anchor="ctr"/>
+          <a:lstStyle/>
+          <a:p>
+            <a:pPr algn="ctr">
+              <a:defRPr sz="1050" b="1">
+                <a:solidFill>
+                  <a:srgbClr val="F59E0B"/>
+                </a:solidFill>
+              </a:defRPr>
+            </a:pPr>
+            <a:r>
+              <a:t>🏆 HACKVERSE 2K26 • ONLINE MID-EVALUATION (GCEK)</a:t>
+            </a:r>
+          </a:p>
+        </p:txBody>
+      </p:sp>
+      <p:sp>
+        <p:nvSpPr>
+          <p:cNvPr id="6" name="TextBox 5"/>
           <p:cNvSpPr txBox="1"/>
           <p:nvPr/>
         </p:nvSpPr>
@@ -3295,7 +3349,7 @@
       </p:sp>
       <p:sp>
         <p:nvSpPr>
-          <p:cNvPr id="6" name="Rounded Rectangle 5"/>
+          <p:cNvPr id="7" name="Rounded Rectangle 6"/>
           <p:cNvSpPr/>
           <p:nvPr/>
         </p:nvSpPr>
@@ -3369,7 +3423,7 @@
       </p:sp>
       <p:sp>
         <p:nvSpPr>
-          <p:cNvPr id="7" name="Rounded Rectangle 6"/>
+          <p:cNvPr id="8" name="Rounded Rectangle 7"/>
           <p:cNvSpPr/>
           <p:nvPr/>
         </p:nvSpPr>
@@ -3443,7 +3497,7 @@
       </p:sp>
       <p:sp>
         <p:nvSpPr>
-          <p:cNvPr id="8" name="Rounded Rectangle 7"/>
+          <p:cNvPr id="9" name="Rounded Rectangle 8"/>
           <p:cNvSpPr/>
           <p:nvPr/>
         </p:nvSpPr>
@@ -3517,7 +3571,7 @@
       </p:sp>
       <p:sp>
         <p:nvSpPr>
-          <p:cNvPr id="9" name="Rounded Rectangle 8"/>
+          <p:cNvPr id="10" name="Rounded Rectangle 9"/>
           <p:cNvSpPr/>
           <p:nvPr/>
         </p:nvSpPr>

</xml_diff>